<commit_message>
Improve data accuracy and credibility by integrating verified external data sources
Integrates verified external data (e.g., Census ACS) into the system, enabling a "credibility ladder" for data claims and improving accuracy. Adds a new evidence vault for manual data uploads and ensures consistency across various data outputs. Fixes metric key mismatches to correctly link fetched data to claims.

Replit-Commit-Author: Agent
Replit-Commit-Session-Id: 8105c9d9-29eb-4730-9087-40eedcafe8c8
Replit-Commit-Checkpoint-Type: full_checkpoint
Replit-Commit-Event-Id: a769f506-1aef-449a-a89a-d52cbe26354e
Replit-Commit-Screenshot-Url: https://storage.googleapis.com/screenshot-production-us-central1/55376bb2-2aea-463e-b6a9-2c1d5c123d53/8105c9d9-29eb-4730-9087-40eedcafe8c8/vZpL2e8
Replit-Helium-Checkpoint-Created: true
</commit_message>
<xml_diff>
--- a/attached_assets/decks/Corridor-Intelligence-Brief-v1.pptx
+++ b/attached_assets/decks/Corridor-Intelligence-Brief-v1.pptx
@@ -2402,7 +2402,7 @@
                 <a:ea typeface="Calibri" pitchFamily="34" charset="-122"/>
                 <a:cs typeface="Calibri" pitchFamily="34" charset="-120"/>
               </a:rPr>
-              <a:t>TCAF · synthesized 4/17/2026, 6:26:36 PM</a:t>
+              <a:t>TCAF · synthesized 4/17/2026, 6:37:48 PM</a:t>
             </a:r>
             <a:endParaRPr lang="en-US" sz="1300" dirty="0"/>
           </a:p>
@@ -11353,7 +11353,7 @@
                 <a:cs typeface="Calibri" pitchFamily="34" charset="-120"/>
               </a:rPr>
               <a:t>3. 3. The fatherhood gap math
-Modeled from the verified Census base: ~4,674 Black children in single-parent households in McLennan and ~12,655 in Travis. Combined Black-male-mentor gap: ~3,812 mentors needed across the corridor.
+Modeled from the verified Census base: ~5,619 Black children in single-parent households in McLennan and ~12,498 in Travis. Combined Black-male-mentor gap: ~3,986 mentors needed across the corridor.
 </a:t>
             </a:r>
             <a:endParaRPr lang="en-US" sz="1200" dirty="0"/>
@@ -13103,7 +13103,7 @@
           </a:solidFill>
           <a:ln w="19050">
             <a:solidFill>
-              <a:srgbClr val="D4A24C"/>
+              <a:srgbClr val="2E7D32"/>
             </a:solidFill>
             <a:prstDash val="solid"/>
           </a:ln>
@@ -13136,13 +13136,13 @@
             <a:r>
               <a:rPr lang="en-US" sz="2600" b="1" dirty="0">
                 <a:solidFill>
-                  <a:srgbClr val="D4A24C"/>
+                  <a:srgbClr val="2E7D32"/>
                 </a:solidFill>
                 <a:latin typeface="Calibri" pitchFamily="34" charset="0"/>
                 <a:ea typeface="Calibri" pitchFamily="34" charset="-122"/>
                 <a:cs typeface="Calibri" pitchFamily="34" charset="-120"/>
               </a:rPr>
-              <a:t>40,469</a:t>
+              <a:t>36,801</a:t>
             </a:r>
             <a:endParaRPr lang="en-US" sz="2600" dirty="0"/>
           </a:p>
@@ -13220,7 +13220,7 @@
                 <a:ea typeface="Calibri" pitchFamily="34" charset="-122"/>
                 <a:cs typeface="Calibri" pitchFamily="34" charset="-120"/>
               </a:rPr>
-              <a:t>[modeled] Modeled from Census ACS county totals × Black population share · 2026-12-31</a:t>
+              <a:t>[verified] U.S. Census Bureau ACS 5-year (2018–2022) — Table B01001B — Sex by Age — Black or African American Alone · 2022-12-31</a:t>
             </a:r>
             <a:endParaRPr lang="en-US" sz="700" dirty="0"/>
           </a:p>
@@ -13245,7 +13245,7 @@
           </a:solidFill>
           <a:ln w="19050">
             <a:solidFill>
-              <a:srgbClr val="D4A24C"/>
+              <a:srgbClr val="9B1C2E"/>
             </a:solidFill>
             <a:prstDash val="solid"/>
           </a:ln>
@@ -13278,13 +13278,13 @@
             <a:r>
               <a:rPr lang="en-US" sz="2600" b="1" dirty="0">
                 <a:solidFill>
-                  <a:srgbClr val="D4A24C"/>
+                  <a:srgbClr val="9B1C2E"/>
                 </a:solidFill>
                 <a:latin typeface="Calibri" pitchFamily="34" charset="0"/>
                 <a:ea typeface="Calibri" pitchFamily="34" charset="-122"/>
                 <a:cs typeface="Calibri" pitchFamily="34" charset="-120"/>
               </a:rPr>
-              <a:t>4,674</a:t>
+              <a:t>5,619</a:t>
             </a:r>
             <a:endParaRPr lang="en-US" sz="2600" dirty="0"/>
           </a:p>
@@ -13362,7 +13362,7 @@
                 <a:ea typeface="Calibri" pitchFamily="34" charset="-122"/>
                 <a:cs typeface="Calibri" pitchFamily="34" charset="-120"/>
               </a:rPr>
-              <a:t>[modeled] Modeled from Census ACS + Kids Count single-parent share · 2026-12-31</a:t>
+              <a:t>[estimated] Verified Census ACS B01001B children 0-17 × 55% single-parent share · 2026-12-31</a:t>
             </a:r>
             <a:endParaRPr lang="en-US" sz="700" dirty="0"/>
           </a:p>
@@ -13387,7 +13387,7 @@
           </a:solidFill>
           <a:ln w="19050">
             <a:solidFill>
-              <a:srgbClr val="D4A24C"/>
+              <a:srgbClr val="9B1C2E"/>
             </a:solidFill>
             <a:prstDash val="solid"/>
           </a:ln>
@@ -13420,13 +13420,13 @@
             <a:r>
               <a:rPr lang="en-US" sz="2600" b="1" dirty="0">
                 <a:solidFill>
-                  <a:srgbClr val="D4A24C"/>
+                  <a:srgbClr val="9B1C2E"/>
                 </a:solidFill>
                 <a:latin typeface="Calibri" pitchFamily="34" charset="0"/>
                 <a:ea typeface="Calibri" pitchFamily="34" charset="-122"/>
                 <a:cs typeface="Calibri" pitchFamily="34" charset="-120"/>
               </a:rPr>
-              <a:t>947</a:t>
+              <a:t>927</a:t>
             </a:r>
             <a:endParaRPr lang="en-US" sz="2600" dirty="0"/>
           </a:p>
@@ -13504,7 +13504,7 @@
                 <a:ea typeface="Calibri" pitchFamily="34" charset="-122"/>
                 <a:cs typeface="Calibri" pitchFamily="34" charset="-120"/>
               </a:rPr>
-              <a:t>[modeled] Modeled from ACS PUMS opportunity-youth methodology · 2026-12-31</a:t>
+              <a:t>[estimated] Verified Census ACS B01001B youth 18-24 × 18% Black disconnection rate · 2026-12-31</a:t>
             </a:r>
             <a:endParaRPr lang="en-US" sz="700" dirty="0"/>
           </a:p>
@@ -13529,7 +13529,7 @@
           </a:solidFill>
           <a:ln w="19050">
             <a:solidFill>
-              <a:srgbClr val="D4A24C"/>
+              <a:srgbClr val="9B1C2E"/>
             </a:solidFill>
             <a:prstDash val="solid"/>
           </a:ln>
@@ -13562,13 +13562,13 @@
             <a:r>
               <a:rPr lang="en-US" sz="2600" b="1" dirty="0">
                 <a:solidFill>
-                  <a:srgbClr val="D4A24C"/>
+                  <a:srgbClr val="9B1C2E"/>
                 </a:solidFill>
                 <a:latin typeface="Calibri" pitchFamily="34" charset="0"/>
                 <a:ea typeface="Calibri" pitchFamily="34" charset="-122"/>
                 <a:cs typeface="Calibri" pitchFamily="34" charset="-120"/>
               </a:rPr>
-              <a:t>1,028</a:t>
+              <a:t>1,236</a:t>
             </a:r>
             <a:endParaRPr lang="en-US" sz="2600" dirty="0"/>
           </a:p>
@@ -13646,7 +13646,7 @@
                 <a:ea typeface="Calibri" pitchFamily="34" charset="-122"/>
                 <a:cs typeface="Calibri" pitchFamily="34" charset="-120"/>
               </a:rPr>
-              <a:t>[modeled] Modeled from BBBS Lone Star public statements + single-parent population · 2026-12-31</a:t>
+              <a:t>[estimated] Derived from verified Census children 0-17 × 55% single-parent share × 22% mentor demand · 2026-12-31</a:t>
             </a:r>
             <a:endParaRPr lang="en-US" sz="700" dirty="0"/>
           </a:p>
@@ -13752,7 +13752,7 @@
                 <a:ea typeface="Calibri" pitchFamily="34" charset="-122"/>
                 <a:cs typeface="Calibri" pitchFamily="34" charset="-120"/>
               </a:rPr>
-              <a:t>Modeled fatherhood gap: ~4,674 Black children in single-parent households → ~1,028 Black-male mentors needed → ~947 disconnected Black youth (16–24).</a:t>
+              <a:t>Modeled fatherhood gap: ~5,619 Black children in single-parent households → ~1,236 Black-male mentors needed → ~927 disconnected Black youth (16–24).</a:t>
             </a:r>
             <a:endParaRPr lang="en-US" sz="1200" dirty="0"/>
           </a:p>
@@ -15456,7 +15456,7 @@
           </a:solidFill>
           <a:ln w="19050">
             <a:solidFill>
-              <a:srgbClr val="D4A24C"/>
+              <a:srgbClr val="2E7D32"/>
             </a:solidFill>
             <a:prstDash val="solid"/>
           </a:ln>
@@ -15489,13 +15489,13 @@
             <a:r>
               <a:rPr lang="en-US" sz="2600" b="1" dirty="0">
                 <a:solidFill>
-                  <a:srgbClr val="D4A24C"/>
+                  <a:srgbClr val="2E7D32"/>
                 </a:solidFill>
                 <a:latin typeface="Calibri" pitchFamily="34" charset="0"/>
                 <a:ea typeface="Calibri" pitchFamily="34" charset="-122"/>
                 <a:cs typeface="Calibri" pitchFamily="34" charset="-120"/>
               </a:rPr>
-              <a:t>109,570</a:t>
+              <a:t>107,055</a:t>
             </a:r>
             <a:endParaRPr lang="en-US" sz="2600" dirty="0"/>
           </a:p>
@@ -15573,7 +15573,7 @@
                 <a:ea typeface="Calibri" pitchFamily="34" charset="-122"/>
                 <a:cs typeface="Calibri" pitchFamily="34" charset="-120"/>
               </a:rPr>
-              <a:t>[modeled] Modeled from Census ACS county totals × Black population share · 2026-12-31</a:t>
+              <a:t>[verified] U.S. Census Bureau ACS 5-year (2018–2022) — Table B01001B — Sex by Age — Black or African American Alone · 2022-12-31</a:t>
             </a:r>
             <a:endParaRPr lang="en-US" sz="700" dirty="0"/>
           </a:p>
@@ -15598,7 +15598,7 @@
           </a:solidFill>
           <a:ln w="19050">
             <a:solidFill>
-              <a:srgbClr val="D4A24C"/>
+              <a:srgbClr val="9B1C2E"/>
             </a:solidFill>
             <a:prstDash val="solid"/>
           </a:ln>
@@ -15631,13 +15631,13 @@
             <a:r>
               <a:rPr lang="en-US" sz="2600" b="1" dirty="0">
                 <a:solidFill>
-                  <a:srgbClr val="D4A24C"/>
+                  <a:srgbClr val="9B1C2E"/>
                 </a:solidFill>
                 <a:latin typeface="Calibri" pitchFamily="34" charset="0"/>
                 <a:ea typeface="Calibri" pitchFamily="34" charset="-122"/>
                 <a:cs typeface="Calibri" pitchFamily="34" charset="-120"/>
               </a:rPr>
-              <a:t>12,655</a:t>
+              <a:t>12,498</a:t>
             </a:r>
             <a:endParaRPr lang="en-US" sz="2600" dirty="0"/>
           </a:p>
@@ -15715,7 +15715,7 @@
                 <a:ea typeface="Calibri" pitchFamily="34" charset="-122"/>
                 <a:cs typeface="Calibri" pitchFamily="34" charset="-120"/>
               </a:rPr>
-              <a:t>[modeled] Modeled from Census ACS + Kids Count single-parent share · 2026-12-31</a:t>
+              <a:t>[estimated] Verified Census ACS B01001B children 0-17 × 55% single-parent share · 2026-12-31</a:t>
             </a:r>
             <a:endParaRPr lang="en-US" sz="700" dirty="0"/>
           </a:p>
@@ -15740,7 +15740,7 @@
           </a:solidFill>
           <a:ln w="19050">
             <a:solidFill>
-              <a:srgbClr val="D4A24C"/>
+              <a:srgbClr val="9B1C2E"/>
             </a:solidFill>
             <a:prstDash val="solid"/>
           </a:ln>
@@ -15773,13 +15773,13 @@
             <a:r>
               <a:rPr lang="en-US" sz="2600" b="1" dirty="0">
                 <a:solidFill>
-                  <a:srgbClr val="D4A24C"/>
+                  <a:srgbClr val="9B1C2E"/>
                 </a:solidFill>
                 <a:latin typeface="Calibri" pitchFamily="34" charset="0"/>
                 <a:ea typeface="Calibri" pitchFamily="34" charset="-122"/>
                 <a:cs typeface="Calibri" pitchFamily="34" charset="-120"/>
               </a:rPr>
-              <a:t>2,564</a:t>
+              <a:t>2,039</a:t>
             </a:r>
             <a:endParaRPr lang="en-US" sz="2600" dirty="0"/>
           </a:p>
@@ -15857,7 +15857,7 @@
                 <a:ea typeface="Calibri" pitchFamily="34" charset="-122"/>
                 <a:cs typeface="Calibri" pitchFamily="34" charset="-120"/>
               </a:rPr>
-              <a:t>[modeled] Modeled from ACS PUMS opportunity-youth methodology · 2026-12-31</a:t>
+              <a:t>[estimated] Verified Census ACS B01001B youth 18-24 × 18% Black disconnection rate · 2026-12-31</a:t>
             </a:r>
             <a:endParaRPr lang="en-US" sz="700" dirty="0"/>
           </a:p>
@@ -15882,7 +15882,7 @@
           </a:solidFill>
           <a:ln w="19050">
             <a:solidFill>
-              <a:srgbClr val="D4A24C"/>
+              <a:srgbClr val="9B1C2E"/>
             </a:solidFill>
             <a:prstDash val="solid"/>
           </a:ln>
@@ -15915,13 +15915,13 @@
             <a:r>
               <a:rPr lang="en-US" sz="2600" b="1" dirty="0">
                 <a:solidFill>
-                  <a:srgbClr val="D4A24C"/>
+                  <a:srgbClr val="9B1C2E"/>
                 </a:solidFill>
                 <a:latin typeface="Calibri" pitchFamily="34" charset="0"/>
                 <a:ea typeface="Calibri" pitchFamily="34" charset="-122"/>
                 <a:cs typeface="Calibri" pitchFamily="34" charset="-120"/>
               </a:rPr>
-              <a:t>2,784</a:t>
+              <a:t>2,750</a:t>
             </a:r>
             <a:endParaRPr lang="en-US" sz="2600" dirty="0"/>
           </a:p>
@@ -15999,7 +15999,7 @@
                 <a:ea typeface="Calibri" pitchFamily="34" charset="-122"/>
                 <a:cs typeface="Calibri" pitchFamily="34" charset="-120"/>
               </a:rPr>
-              <a:t>[modeled] Modeled from BBBS Lone Star public statements + single-parent population · 2026-12-31</a:t>
+              <a:t>[estimated] Derived from verified Census children 0-17 × 55% single-parent share × 22% mentor demand · 2026-12-31</a:t>
             </a:r>
             <a:endParaRPr lang="en-US" sz="700" dirty="0"/>
           </a:p>
@@ -16105,7 +16105,7 @@
                 <a:ea typeface="Calibri" pitchFamily="34" charset="-122"/>
                 <a:cs typeface="Calibri" pitchFamily="34" charset="-120"/>
               </a:rPr>
-              <a:t>Modeled fatherhood gap: ~12,655 Black children in single-parent households → ~2,784 Black-male mentors needed → ~2,564 disconnected Black youth (16–24).</a:t>
+              <a:t>Modeled fatherhood gap: ~12,498 Black children in single-parent households → ~2,750 Black-male mentors needed → ~2,039 disconnected Black youth (16–24).</a:t>
             </a:r>
             <a:endParaRPr lang="en-US" sz="1200" dirty="0"/>
           </a:p>

</xml_diff>